<commit_message>
Use solo wording across the README, decks, PDFs, demo pages and video
</commit_message>
<xml_diff>
--- a/deck/OwlContinuity_Detailed_Deck.pptx
+++ b/deck/OwlContinuity_Detailed_Deck.pptx
@@ -327,6 +327,10 @@
           </p:nvPr>
         </p:nvSpPr>
         <p:spPr/>
+        <p:txBody>
+          <a:bodyPr/>
+          <a:p/>
+        </p:txBody>
       </p:sp>
       <p:sp>
         <p:nvSpPr>
@@ -353,13 +357,13 @@
             </a:r>
             <a:r>
               <a:rPr dirty="0"/>
-              <a:t> checks those consequences and drafts a schedule the professor can review. Our main feature is the Domino Effect Agent. A supporting assignment helper explains the professor’s approved instructions to students.”</a:t>
+              <a:t> checks those consequences and drafts a schedule the professor can review. The main feature is the Domino Effect Agent. A supporting assignment helper explains the professor’s approved instructions to students.”</a:t>
             </a:r>
           </a:p>
           <a:p>
             <a:r>
               <a:rPr dirty="0"/>
-              <a:t>Transition: “Here is the deadline problem we solve.”</a:t>
+              <a:t>Transition: “Here is the deadline problem I solve.”</a:t>
             </a:r>
           </a:p>
           <a:p>
@@ -414,6 +418,10 @@
           </p:nvPr>
         </p:nvSpPr>
         <p:spPr/>
+        <p:txBody>
+          <a:bodyPr/>
+          <a:p/>
+        </p:txBody>
       </p:sp>
     </p:spTree>
   </p:cSld>
@@ -451,6 +459,10 @@
           </p:nvPr>
         </p:nvSpPr>
         <p:spPr/>
+        <p:txBody>
+          <a:bodyPr/>
+          <a:p/>
+        </p:txBody>
       </p:sp>
       <p:sp>
         <p:nvSpPr>
@@ -491,6 +503,10 @@
           </p:nvPr>
         </p:nvSpPr>
         <p:spPr/>
+        <p:txBody>
+          <a:bodyPr/>
+          <a:p/>
+        </p:txBody>
       </p:sp>
     </p:spTree>
   </p:cSld>
@@ -528,6 +544,10 @@
           </p:nvPr>
         </p:nvSpPr>
         <p:spPr/>
+        <p:txBody>
+          <a:bodyPr/>
+          <a:p/>
+        </p:txBody>
       </p:sp>
       <p:sp>
         <p:nvSpPr>
@@ -616,6 +636,10 @@
           </p:nvPr>
         </p:nvSpPr>
         <p:spPr/>
+        <p:txBody>
+          <a:bodyPr/>
+          <a:p/>
+        </p:txBody>
       </p:sp>
     </p:spTree>
   </p:cSld>
@@ -653,6 +677,10 @@
           </p:nvPr>
         </p:nvSpPr>
         <p:spPr/>
+        <p:txBody>
+          <a:bodyPr/>
+          <a:p/>
+        </p:txBody>
       </p:sp>
       <p:sp>
         <p:nvSpPr>
@@ -730,6 +758,10 @@
           </p:nvPr>
         </p:nvSpPr>
         <p:spPr/>
+        <p:txBody>
+          <a:bodyPr/>
+          <a:p/>
+        </p:txBody>
       </p:sp>
     </p:spTree>
   </p:cSld>
@@ -767,6 +799,10 @@
           </p:nvPr>
         </p:nvSpPr>
         <p:spPr/>
+        <p:txBody>
+          <a:bodyPr/>
+          <a:p/>
+        </p:txBody>
       </p:sp>
       <p:sp>
         <p:nvSpPr>
@@ -826,6 +862,10 @@
           </p:nvPr>
         </p:nvSpPr>
         <p:spPr/>
+        <p:txBody>
+          <a:bodyPr/>
+          <a:p/>
+        </p:txBody>
       </p:sp>
     </p:spTree>
   </p:cSld>
@@ -863,6 +903,10 @@
           </p:nvPr>
         </p:nvSpPr>
         <p:spPr/>
+        <p:txBody>
+          <a:bodyPr/>
+          <a:p/>
+        </p:txBody>
       </p:sp>
       <p:sp>
         <p:nvSpPr>
@@ -885,7 +929,7 @@
           </a:p>
           <a:p>
             <a:r>
-              <a:t>Preparation: open Instructor Desk in the existing demo chat where the initial schedule and first closure have already been supplied. Paste the original extended-closure prompt (file 03 in the team’s kit). Do not reconstruct the full input from this slide. Start the request before this slide if needed.</a:t>
+              <a:t>Preparation: open Instructor Desk in the existing demo chat where the initial schedule and first closure have already been supplied. Paste the original extended-closure prompt (file 03 in the project kit). Do not reconstruct the full input from this slide. Start the request before this slide if needed.</a:t>
             </a:r>
           </a:p>
           <a:p>
@@ -910,7 +954,7 @@
           </a:p>
           <a:p>
             <a:r>
-              <a:t>If the live run fails, show the recorded-run slides (full deck OwlContinuity_Final_Pitch_Designed_v6.pptx, slides 38–44) and state clearly: “This is a recorded run from our testing.” The screenshots are actual assets from the supplied deck.</a:t>
+              <a:t>If the live run fails, show the recorded-run slides (detailed deck OwlContinuity_Detailed_Deck.pptx, slides 42–48) and state clearly: “This is a recorded run from my testing.” The screenshots are actual assets from the supplied deck.</a:t>
             </a:r>
           </a:p>
           <a:p>
@@ -939,6 +983,10 @@
           </p:nvPr>
         </p:nvSpPr>
         <p:spPr/>
+        <p:txBody>
+          <a:bodyPr/>
+          <a:p/>
+        </p:txBody>
       </p:sp>
     </p:spTree>
   </p:cSld>
@@ -976,6 +1024,10 @@
           </p:nvPr>
         </p:nvSpPr>
         <p:spPr/>
+        <p:txBody>
+          <a:bodyPr/>
+          <a:p/>
+        </p:txBody>
       </p:sp>
       <p:sp>
         <p:nvSpPr>
@@ -993,12 +1045,12 @@
           <a:lstStyle/>
           <a:p>
             <a:r>
-              <a:t>About 35 seconds: “Our reported main check has 31 passes, two partial results and no failures, plus seven successful assignment-rule questions. The two partials matter. The carry-over review was overcautious, and an invalid date still led to a conditional plan. Testing also prompted the timezone calculation rule and a fix for the new-question message tag.”</a:t>
-            </a:r>
-          </a:p>
-          <a:p>
-            <a:r>
-              <a:t>These are team-reported prototype results from the October 16 test summary. The test set is small and team-written, and the six held-back cases are not an independent evaluation. Do not treat a zero failure count in this report as proof of reliability.</a:t>
+              <a:t>About 35 seconds: “The main test report has 31 passes, two partial results and no failures, plus seven successful assignment-rule questions. The two partials matter. The carry-over review was overcautious, and an invalid date still led to a conditional plan. Testing also prompted the timezone calculation rule and a fix for the new-question message tag.”</a:t>
+            </a:r>
+          </a:p>
+          <a:p>
+            <a:r>
+              <a:t>These are self-reported prototype results from the October 16 test summary. The test set is small and I wrote it myself, and the six held-back cases are not an independent evaluation. Do not treat a zero failure count in this report as proof of reliability.</a:t>
             </a:r>
           </a:p>
           <a:p>
@@ -1021,7 +1073,7 @@
           </a:p>
           <a:p>
             <a:r>
-              <a:t>On October 17 we re-ran the domino twice: both runs had the right plan, and in one run the agent also moved the review when it didn't need to, which is why every plan stays a draft.</a:t>
+              <a:t>On October 17 I re-ran the domino twice: both runs had the right plan, and in one run the agent also moved the review when it didn't need to, which is why every plan stays a draft.</a:t>
             </a:r>
           </a:p>
         </p:txBody>
@@ -1037,6 +1089,10 @@
           </p:nvPr>
         </p:nvSpPr>
         <p:spPr/>
+        <p:txBody>
+          <a:bodyPr/>
+          <a:p/>
+        </p:txBody>
       </p:sp>
     </p:spTree>
   </p:cSld>
@@ -1074,6 +1130,10 @@
           </p:nvPr>
         </p:nvSpPr>
         <p:spPr/>
+        <p:txBody>
+          <a:bodyPr/>
+          <a:p/>
+        </p:txBody>
       </p:sp>
       <p:sp>
         <p:nvSpPr>
@@ -1091,12 +1151,12 @@
           <a:lstStyle/>
           <a:p>
             <a:r>
-              <a:t>About 25 seconds: “We didn’t want to test only on our made-up course, so we gave the agents a real FAU syllabus, DEMO-202. All 17 live tests passed. Here is the domino on the real course: a closure cancels the class where Project Part 3 is announced. The make-up is Monday, November 9. The old due date, November 19, would give only 250 hours when the rule needs 336, so the agent moves it to November 23 and shows the math. The student side followed this course’s stricter AI ban and gave the textbook link exactly as posted.”</a:t>
-            </a:r>
-          </a:p>
-          <a:p>
-            <a:r>
-              <a:t>Honest limits: the closure, exact class days and approved answers are team test values set by Tanvir, not the instructor’s decisions. One run per test; team-written tests.</a:t>
+              <a:t>About 25 seconds: “I didn’t want to test only on the made-up course, so I gave the agents a real FAU syllabus, DEMO-202. All 17 live tests passed. Here is the domino on the real course: a closure cancels the class where Project Part 3 is announced. The make-up is Monday, November 9. The old due date, November 19, would give only 250 hours when the rule needs 336, so the agent moves it to November 23 and shows the math. The student side followed this course’s stricter AI ban and gave the textbook link exactly as posted.”</a:t>
+            </a:r>
+          </a:p>
+          <a:p>
+            <a:r>
+              <a:t>Honest limits: the closure, exact class days and approved answers are test values I set, not the instructor’s decisions. One run per test; I wrote the tests myself.</a:t>
             </a:r>
           </a:p>
           <a:p>
@@ -1117,6 +1177,10 @@
           </p:nvPr>
         </p:nvSpPr>
         <p:spPr/>
+        <p:txBody>
+          <a:bodyPr/>
+          <a:p/>
+        </p:txBody>
       </p:sp>
     </p:spTree>
   </p:cSld>
@@ -1154,6 +1218,10 @@
           </p:nvPr>
         </p:nvSpPr>
         <p:spPr/>
+        <p:txBody>
+          <a:bodyPr/>
+          <a:p/>
+        </p:txBody>
       </p:sp>
       <p:sp>
         <p:nvSpPr>
@@ -1171,7 +1239,7 @@
           <a:lstStyle/>
           <a:p>
             <a:r>
-              <a:t>About 25 seconds: “On the left are the real rules from the DEMO-202 syllabus: no final exam, quizzes in person, a late penalty of 10 and 20 percent, and a full AI ban. The syllabus only lists weeks, so to test the domino we set exact days and two simple rules, shown on the right: Quiz 3 needs 48 hours after the prep lecture, and Project Part 3 needs 14 days after it is announced. These are our test values, not the instructor’s decisions.”</a:t>
+              <a:t>About 25 seconds: “On the left are the real rules from the DEMO-202 syllabus: no final exam, quizzes in person, a late penalty of 10 and 20 percent, and a full AI ban. The syllabus only lists weeks, so to test the domino I set exact days and two simple rules, shown on the right: Quiz 3 needs 48 hours after the prep lecture, and Project Part 3 needs 14 days after it is announced. These are my test values, not the instructor’s decisions.”</a:t>
             </a:r>
           </a:p>
           <a:p>
@@ -1192,6 +1260,10 @@
           </p:nvPr>
         </p:nvSpPr>
         <p:spPr/>
+        <p:txBody>
+          <a:bodyPr/>
+          <a:p/>
+        </p:txBody>
       </p:sp>
     </p:spTree>
   </p:cSld>
@@ -1229,6 +1301,10 @@
           </p:nvPr>
         </p:nvSpPr>
         <p:spPr/>
+        <p:txBody>
+          <a:bodyPr/>
+          <a:p/>
+        </p:txBody>
       </p:sp>
       <p:sp>
         <p:nvSpPr>
@@ -1251,7 +1327,7 @@
           </a:p>
           <a:p>
             <a:r>
-              <a:t>These are team-written cases, not an independent evaluation. H03 remains PARTIAL in the final tally.</a:t>
+              <a:t>These are cases I wrote myself, not an independent evaluation. H03 remains PARTIAL in the final tally.</a:t>
             </a:r>
           </a:p>
           <a:p>
@@ -1288,6 +1364,10 @@
           </p:nvPr>
         </p:nvSpPr>
         <p:spPr/>
+        <p:txBody>
+          <a:bodyPr/>
+          <a:p/>
+        </p:txBody>
       </p:sp>
     </p:spTree>
   </p:cSld>
@@ -1325,6 +1405,10 @@
           </p:nvPr>
         </p:nvSpPr>
         <p:spPr/>
+        <p:txBody>
+          <a:bodyPr/>
+          <a:p/>
+        </p:txBody>
       </p:sp>
       <p:sp>
         <p:nvSpPr>
@@ -1342,7 +1426,7 @@
           <a:lstStyle/>
           <a:p>
             <a:r>
-              <a:t>About 25 seconds: “We are clear about the limits. Dates and calculations still need human checking, invalid dates need a better response, and dated answers must be refreshed after each change. The prototype needs no grades or student records, applies the course AI policy, keeps personal cases private and leaves every published change to the professor. It does not book rooms or know other courses.”</a:t>
+              <a:t>About 25 seconds: “I'm clear about the limits. Dates and calculations still need human checking, invalid dates need a better response, and dated answers must be refreshed after each change. The prototype needs no grades or student records, applies the course AI policy, keeps personal cases private and leaves every published change to the professor. It does not book rooms or know other courses.”</a:t>
             </a:r>
           </a:p>
           <a:p>
@@ -1384,6 +1468,10 @@
           </p:nvPr>
         </p:nvSpPr>
         <p:spPr/>
+        <p:txBody>
+          <a:bodyPr/>
+          <a:p/>
+        </p:txBody>
       </p:sp>
     </p:spTree>
   </p:cSld>
@@ -1421,6 +1509,10 @@
           </p:nvPr>
         </p:nvSpPr>
         <p:spPr/>
+        <p:txBody>
+          <a:bodyPr/>
+          <a:p/>
+        </p:txBody>
       </p:sp>
       <p:sp>
         <p:nvSpPr>
@@ -1509,6 +1601,10 @@
           </p:nvPr>
         </p:nvSpPr>
         <p:spPr/>
+        <p:txBody>
+          <a:bodyPr/>
+          <a:p/>
+        </p:txBody>
       </p:sp>
     </p:spTree>
   </p:cSld>
@@ -1546,6 +1642,10 @@
           </p:nvPr>
         </p:nvSpPr>
         <p:spPr/>
+        <p:txBody>
+          <a:bodyPr/>
+          <a:p/>
+        </p:txBody>
       </p:sp>
       <p:sp>
         <p:nvSpPr>
@@ -1563,7 +1663,7 @@
           <a:lstStyle/>
           <a:p>
             <a:r>
-              <a:t>About 30 seconds: “The prototype uses owlONE and two personal agents. A realistic next step is one semester with a few volunteer professors. We should measure how long it takes to produce a plan that passes review, whether conflicts remain, and how quickly students get accurate answers. We must confirm the sharing and approval process before classroom use. Canvas routing and automatic bank updates are future work.”</a:t>
+              <a:t>About 30 seconds: “The prototype uses owlONE and two personal agents. A realistic next step is one semester with a few volunteer professors. A pilot should measure how long it takes to produce a plan that passes review, whether conflicts remain, and how quickly students get accurate answers. The sharing and approval process must be confirmed before classroom use. Canvas routing and automatic bank updates are future work.”</a:t>
             </a:r>
           </a:p>
           <a:p>
@@ -1597,6 +1697,10 @@
           </p:nvPr>
         </p:nvSpPr>
         <p:spPr/>
+        <p:txBody>
+          <a:bodyPr/>
+          <a:p/>
+        </p:txBody>
       </p:sp>
     </p:spTree>
   </p:cSld>
@@ -1634,6 +1738,10 @@
           </p:nvPr>
         </p:nvSpPr>
         <p:spPr/>
+        <p:txBody>
+          <a:bodyPr/>
+          <a:p/>
+        </p:txBody>
       </p:sp>
       <p:sp>
         <p:nvSpPr>
@@ -1651,7 +1759,7 @@
           <a:lstStyle/>
           <a:p>
             <a:r>
-              <a:t>Closing, about 15 seconds: “OwlContinuity gives the professor a revised schedule with the consequences made visible. The assignment helper then explains approved requirements to students. We propose a supervised pilot with two or three volunteer professors to measure whether it reduces rescheduling work and student confusion.”</a:t>
+              <a:t>Closing, about 15 seconds: “OwlContinuity gives the professor a revised schedule with the consequences made visible. The assignment helper then explains approved requirements to students. I propose a supervised pilot with two or three volunteer professors to measure whether it reduces rescheduling work and student confusion.”</a:t>
             </a:r>
           </a:p>
           <a:p>
@@ -1685,6 +1793,10 @@
           </p:nvPr>
         </p:nvSpPr>
         <p:spPr/>
+        <p:txBody>
+          <a:bodyPr/>
+          <a:p/>
+        </p:txBody>
       </p:sp>
     </p:spTree>
   </p:cSld>
@@ -1722,6 +1834,10 @@
           </p:nvPr>
         </p:nvSpPr>
         <p:spPr/>
+        <p:txBody>
+          <a:bodyPr/>
+          <a:p/>
+        </p:txBody>
       </p:sp>
       <p:sp>
         <p:nvSpPr>
@@ -1753,6 +1869,10 @@
           </p:nvPr>
         </p:nvSpPr>
         <p:spPr/>
+        <p:txBody>
+          <a:bodyPr/>
+          <a:p/>
+        </p:txBody>
       </p:sp>
     </p:spTree>
   </p:cSld>
@@ -2214,6 +2334,10 @@
           </p:nvPr>
         </p:nvSpPr>
         <p:spPr/>
+        <p:txBody>
+          <a:bodyPr/>
+          <a:p/>
+        </p:txBody>
       </p:sp>
       <p:sp>
         <p:nvSpPr>
@@ -2232,7 +2356,7 @@
           <a:p>
             <a:r>
               <a:rPr dirty="0"/>
-              <a:t>About 30 seconds: “The difficult part is not choosing a new date. It is checking what depends on that date. A lesson prepares students for the lab and quiz. The lab supplies the work needed for the memo. The final remains fixed. A rushed update can leave students too little time to finish. We support the professor who has to check this whole sequence.”</a:t>
+              <a:t>About 30 seconds: “The difficult part is not choosing a new date. It is checking what depends on that date. A lesson prepares students for the lab and quiz. The lab supplies the work needed for the memo. The final remains fixed. A rushed update can leave students too little time to finish. It supports the professor who has to check this whole sequence.”</a:t>
             </a:r>
           </a:p>
           <a:p>
@@ -2285,6 +2409,10 @@
           </p:nvPr>
         </p:nvSpPr>
         <p:spPr/>
+        <p:txBody>
+          <a:bodyPr/>
+          <a:p/>
+        </p:txBody>
       </p:sp>
     </p:spTree>
   </p:cSld>
@@ -2446,7 +2574,7 @@
           <a:lstStyle/>
           <a:p>
             <a:r>
-              <a:t>These results come from the team’s test summary. The saved test outputs provide the detailed evidence. The recorded demonstration screenshots show selected examples.</a:t>
+              <a:t>These results come from my test summary. The saved test outputs provide the detailed evidence. The recorded demonstration screenshots show selected examples.</a:t>
             </a:r>
           </a:p>
           <a:p>
@@ -2513,7 +2641,7 @@
           <a:lstStyle/>
           <a:p>
             <a:r>
-              <a:t>Use when judges ask about conflicting notices, prompt injection, missing facts or impossible schedules. These are team-written test cases with fictional notices. Do not present them as an independent evaluation. H03 remains PARTIAL in the final tally.</a:t>
+              <a:t>Use when judges ask about conflicting notices, prompt injection, missing facts or impossible schedules. These are test cases I wrote, with fictional notices. Do not present them as an independent evaluation. H03 remains PARTIAL in the final tally.</a:t>
             </a:r>
           </a:p>
           <a:p/>
@@ -2570,7 +2698,7 @@
           <a:lstStyle/>
           <a:p>
             <a:r>
-              <a:t>The important honest answer is that the plain chat also found the correct plan. The team observed about 90 seconds versus about nine minutes in one run each. The plain chat’s reported wrong duration was 174 h 10 m instead of 170 h 10 m. Do not describe these observations as a controlled benchmark, a guaranteed six-fold speedup or proof that an ordinary chatbot cannot detect dependencies.</a:t>
+              <a:t>The important honest answer is that the plain chat also found the correct plan. I observed about 90 seconds versus about nine minutes in one run each. The plain chat’s reported wrong duration was 174 h 10 m instead of 170 h 10 m. Do not describe these observations as a controlled benchmark, a guaranteed six-fold speedup or proof that an ordinary chatbot cannot detect dependencies.</a:t>
             </a:r>
           </a:p>
           <a:p/>
@@ -2922,6 +3050,10 @@
           </p:nvPr>
         </p:nvSpPr>
         <p:spPr/>
+        <p:txBody>
+          <a:bodyPr/>
+          <a:p/>
+        </p:txBody>
       </p:sp>
       <p:sp>
         <p:nvSpPr>
@@ -2999,6 +3131,10 @@
           </p:nvPr>
         </p:nvSpPr>
         <p:spPr/>
+        <p:txBody>
+          <a:bodyPr/>
+          <a:p/>
+        </p:txBody>
       </p:sp>
     </p:spTree>
   </p:cSld>
@@ -3600,6 +3736,10 @@
           </p:nvPr>
         </p:nvSpPr>
         <p:spPr/>
+        <p:txBody>
+          <a:bodyPr/>
+          <a:p/>
+        </p:txBody>
       </p:sp>
       <p:sp>
         <p:nvSpPr>
@@ -3640,6 +3780,10 @@
           </p:nvPr>
         </p:nvSpPr>
         <p:spPr/>
+        <p:txBody>
+          <a:bodyPr/>
+          <a:p/>
+        </p:txBody>
       </p:sp>
     </p:spTree>
   </p:cSld>
@@ -3677,6 +3821,10 @@
           </p:nvPr>
         </p:nvSpPr>
         <p:spPr/>
+        <p:txBody>
+          <a:bodyPr/>
+          <a:p/>
+        </p:txBody>
       </p:sp>
       <p:sp>
         <p:nvSpPr>
@@ -3764,6 +3912,10 @@
           </p:nvPr>
         </p:nvSpPr>
         <p:spPr/>
+        <p:txBody>
+          <a:bodyPr/>
+          <a:p/>
+        </p:txBody>
       </p:sp>
     </p:spTree>
   </p:cSld>
@@ -3801,6 +3953,10 @@
           </p:nvPr>
         </p:nvSpPr>
         <p:spPr/>
+        <p:txBody>
+          <a:bodyPr/>
+          <a:p/>
+        </p:txBody>
       </p:sp>
       <p:sp>
         <p:nvSpPr>
@@ -3875,6 +4031,10 @@
           </p:nvPr>
         </p:nvSpPr>
         <p:spPr/>
+        <p:txBody>
+          <a:bodyPr/>
+          <a:p/>
+        </p:txBody>
       </p:sp>
     </p:spTree>
   </p:cSld>
@@ -3912,6 +4072,10 @@
           </p:nvPr>
         </p:nvSpPr>
         <p:spPr/>
+        <p:txBody>
+          <a:bodyPr/>
+          <a:p/>
+        </p:txBody>
       </p:sp>
       <p:sp>
         <p:nvSpPr>
@@ -3992,6 +4156,10 @@
           </p:nvPr>
         </p:nvSpPr>
         <p:spPr/>
+        <p:txBody>
+          <a:bodyPr/>
+          <a:p/>
+        </p:txBody>
       </p:sp>
     </p:spTree>
   </p:cSld>
@@ -4029,6 +4197,10 @@
           </p:nvPr>
         </p:nvSpPr>
         <p:spPr/>
+        <p:txBody>
+          <a:bodyPr/>
+          <a:p/>
+        </p:txBody>
       </p:sp>
       <p:sp>
         <p:nvSpPr>
@@ -4047,7 +4219,7 @@
           <a:p>
             <a:r>
               <a:rPr dirty="0"/>
-              <a:t>About 35 seconds: “The professor side checks whether the assignment instructions are clear. The student side explains the instructions as a checklist and answers practical questions from approved sources. For example, our memo prompt mentions pages and the rubric mentions a word limit. The helper shows both and asks for clarification instead of inventing which one wins. It helps students understand the task while leaving the graded work to them.”</a:t>
+              <a:t>About 35 seconds: “The professor side checks whether the assignment instructions are clear. The student side explains the instructions as a checklist and answers practical questions from approved sources. For example, the demo memo prompt mentions pages and the rubric mentions a word limit. The helper shows both and asks for clarification instead of inventing which one wins. It helps students understand the task while leaving the graded work to them.”</a:t>
             </a:r>
           </a:p>
           <a:p>
@@ -4100,6 +4272,10 @@
           </p:nvPr>
         </p:nvSpPr>
         <p:spPr/>
+        <p:txBody>
+          <a:bodyPr/>
+          <a:p/>
+        </p:txBody>
       </p:sp>
     </p:spTree>
   </p:cSld>
@@ -7294,7 +7470,7 @@
                 </a:solidFill>
                 <a:latin typeface="Avenir Next"/>
               </a:rPr>
-              <a:t>FAU owlONE Promptathon   /   October 17, 2026   /   Team OwlContinuity</a:t>
+              <a:t>FAU owlONE Promptathon   /   October 17, 2026</a:t>
             </a:r>
           </a:p>
         </p:txBody>
@@ -14043,7 +14219,7 @@
                 </a:solidFill>
                 <a:latin typeface="Avenir Next"/>
               </a:rPr>
-              <a:t>Team testing in owlONE on October 16–17, 2026, using the fictional DEMO-101 course.</a:t>
+              <a:t>Tested in owlONE on October 16–17, 2026, using the fictional DEMO-101 course.</a:t>
             </a:r>
           </a:p>
         </p:txBody>
@@ -16687,7 +16863,7 @@
                 </a:solidFill>
                 <a:latin typeface="Avenir Next"/>
               </a:rPr>
-              <a:t>Real syllabus text. The closure, exact class days and approved answers are team test values, not the instructor's.</a:t>
+              <a:t>Real syllabus text. The closure, exact class days and approved answers are my test values, not the instructor's.</a:t>
             </a:r>
           </a:p>
         </p:txBody>
@@ -16747,7 +16923,7 @@
                 </a:solidFill>
                 <a:latin typeface="Avenir Next"/>
               </a:rPr>
-              <a:t>The rules we tested on DEMO-202</a:t>
+              <a:t>The rules I tested on DEMO-202</a:t>
             </a:r>
           </a:p>
         </p:txBody>
@@ -16782,7 +16958,7 @@
                 </a:solidFill>
                 <a:latin typeface="Avenir Next"/>
               </a:rPr>
-              <a:t>Left: the real syllabus. Right: the values our team set, because the syllabus lists weeks, not days.</a:t>
+              <a:t>Left: the real syllabus. Right: the values I set, because the syllabus lists weeks, not days.</a:t>
             </a:r>
           </a:p>
         </p:txBody>
@@ -17169,7 +17345,7 @@
                 </a:solidFill>
                 <a:latin typeface="Avenir Next"/>
               </a:rPr>
-              <a:t>WHAT OUR TEAM SET FOR TESTING</a:t>
+              <a:t>WHAT I SET FOR TESTING</a:t>
             </a:r>
           </a:p>
         </p:txBody>
@@ -17562,7 +17738,7 @@
                 </a:solidFill>
                 <a:latin typeface="Avenir Next"/>
               </a:rPr>
-              <a:t>The right side is not the instructor’s decisions. Tanvir set these values to test the agents on October 17, 2026.</a:t>
+              <a:t>The right side is not the instructor’s decisions. I set these values to test the agents on October 17, 2026.</a:t>
             </a:r>
           </a:p>
         </p:txBody>
@@ -17665,7 +17841,7 @@
                 </a:solidFill>
                 <a:latin typeface="Avenir Next"/>
               </a:rPr>
-              <a:t>Team-written hard cases from the October 16 tests, with fictional notices.</a:t>
+              <a:t>Hard cases I wrote for the October 16 tests, with fictional notices.</a:t>
             </a:r>
           </a:p>
         </p:txBody>
@@ -24109,7 +24285,7 @@
                 </a:solidFill>
                 <a:latin typeface="Avenir Next"/>
               </a:rPr>
-              <a:t>Expected results come from our October 16–17 test runs. If a run fails twice, we show the saved result from our testing.</a:t>
+              <a:t>Expected results come from my October 16–17 test runs. If a run fails twice, I show the saved result from my testing.</a:t>
             </a:r>
           </a:p>
         </p:txBody>
@@ -35493,7 +35669,7 @@
                 </a:solidFill>
                 <a:latin typeface="Avenir Next"/>
               </a:rPr>
-              <a:t>Small, team-written tests. The prototype has not yet undergone a real-course evaluation.</a:t>
+              <a:t>Small test sets I wrote myself. The prototype has not yet undergone a real-course evaluation.</a:t>
             </a:r>
           </a:p>
         </p:txBody>
@@ -36973,7 +37149,7 @@
                 </a:solidFill>
                 <a:latin typeface="Avenir Next"/>
               </a:rPr>
-              <a:t>Same model and inputs in the team’s report. One run for each workflow.</a:t>
+              <a:t>Same model and inputs in my test report. One run for each workflow.</a:t>
             </a:r>
           </a:p>
         </p:txBody>
@@ -41863,7 +42039,7 @@
                 </a:solidFill>
                 <a:latin typeface="Avenir Next"/>
               </a:rPr>
-              <a:t>Real-world savings have not been measured. We have a fictional workload estimate and a small exploratory comparison.</a:t>
+              <a:t>Real-world savings have not been measured. I have a fictional workload estimate and a small exploratory comparison.</a:t>
             </a:r>
           </a:p>
         </p:txBody>
@@ -48138,7 +48314,7 @@
                 </a:solidFill>
                 <a:latin typeface="Avenir Next"/>
               </a:rPr>
-              <a:t>Live in owlONE, October 17, 2026. Real syllabus; closure, exact days and answers are team test values.</a:t>
+              <a:t>Live in owlONE, October 17, 2026. Real syllabus; closure, exact days and answers are my test values.</a:t>
             </a:r>
           </a:p>
         </p:txBody>
@@ -50350,7 +50526,7 @@
                 </a:solidFill>
                 <a:latin typeface="Avenir Next"/>
               </a:rPr>
-              <a:t>Written in plain words by the professor of our practice course. The agent turns each one into a check it can measure.</a:t>
+              <a:t>Written in plain words by the professor of the practice course. The agent turns each one into a check it can measure.</a:t>
             </a:r>
           </a:p>
         </p:txBody>

</xml_diff>